<commit_message>
replace background image and add Seargin/Roche in CV
</commit_message>
<xml_diff>
--- a/assets/ppt/PK_CV.pptx
+++ b/assets/ppt/PK_CV.pptx
@@ -243,7 +243,7 @@
           <a:p>
             <a:fld id="{FEA1A487-9522-4098-8ABE-F66374D5ED78}" type="datetimeFigureOut">
               <a:rPr lang="en-US" smtClean="0"/>
-              <a:t>2020-12-19</a:t>
+              <a:t>2021-02-01</a:t>
             </a:fld>
             <a:endParaRPr lang="en-US"/>
           </a:p>
@@ -413,7 +413,7 @@
           <a:p>
             <a:fld id="{FEA1A487-9522-4098-8ABE-F66374D5ED78}" type="datetimeFigureOut">
               <a:rPr lang="en-US" smtClean="0"/>
-              <a:t>2020-12-19</a:t>
+              <a:t>2021-02-01</a:t>
             </a:fld>
             <a:endParaRPr lang="en-US"/>
           </a:p>
@@ -593,7 +593,7 @@
           <a:p>
             <a:fld id="{FEA1A487-9522-4098-8ABE-F66374D5ED78}" type="datetimeFigureOut">
               <a:rPr lang="en-US" smtClean="0"/>
-              <a:t>2020-12-19</a:t>
+              <a:t>2021-02-01</a:t>
             </a:fld>
             <a:endParaRPr lang="en-US"/>
           </a:p>
@@ -763,7 +763,7 @@
           <a:p>
             <a:fld id="{FEA1A487-9522-4098-8ABE-F66374D5ED78}" type="datetimeFigureOut">
               <a:rPr lang="en-US" smtClean="0"/>
-              <a:t>2020-12-19</a:t>
+              <a:t>2021-02-01</a:t>
             </a:fld>
             <a:endParaRPr lang="en-US"/>
           </a:p>
@@ -1007,7 +1007,7 @@
           <a:p>
             <a:fld id="{FEA1A487-9522-4098-8ABE-F66374D5ED78}" type="datetimeFigureOut">
               <a:rPr lang="en-US" smtClean="0"/>
-              <a:t>2020-12-19</a:t>
+              <a:t>2021-02-01</a:t>
             </a:fld>
             <a:endParaRPr lang="en-US"/>
           </a:p>
@@ -1239,7 +1239,7 @@
           <a:p>
             <a:fld id="{FEA1A487-9522-4098-8ABE-F66374D5ED78}" type="datetimeFigureOut">
               <a:rPr lang="en-US" smtClean="0"/>
-              <a:t>2020-12-19</a:t>
+              <a:t>2021-02-01</a:t>
             </a:fld>
             <a:endParaRPr lang="en-US"/>
           </a:p>
@@ -1606,7 +1606,7 @@
           <a:p>
             <a:fld id="{FEA1A487-9522-4098-8ABE-F66374D5ED78}" type="datetimeFigureOut">
               <a:rPr lang="en-US" smtClean="0"/>
-              <a:t>2020-12-19</a:t>
+              <a:t>2021-02-01</a:t>
             </a:fld>
             <a:endParaRPr lang="en-US"/>
           </a:p>
@@ -1724,7 +1724,7 @@
           <a:p>
             <a:fld id="{FEA1A487-9522-4098-8ABE-F66374D5ED78}" type="datetimeFigureOut">
               <a:rPr lang="en-US" smtClean="0"/>
-              <a:t>2020-12-19</a:t>
+              <a:t>2021-02-01</a:t>
             </a:fld>
             <a:endParaRPr lang="en-US"/>
           </a:p>
@@ -1819,7 +1819,7 @@
           <a:p>
             <a:fld id="{FEA1A487-9522-4098-8ABE-F66374D5ED78}" type="datetimeFigureOut">
               <a:rPr lang="en-US" smtClean="0"/>
-              <a:t>2020-12-19</a:t>
+              <a:t>2021-02-01</a:t>
             </a:fld>
             <a:endParaRPr lang="en-US"/>
           </a:p>
@@ -2096,7 +2096,7 @@
           <a:p>
             <a:fld id="{FEA1A487-9522-4098-8ABE-F66374D5ED78}" type="datetimeFigureOut">
               <a:rPr lang="en-US" smtClean="0"/>
-              <a:t>2020-12-19</a:t>
+              <a:t>2021-02-01</a:t>
             </a:fld>
             <a:endParaRPr lang="en-US"/>
           </a:p>
@@ -2353,7 +2353,7 @@
           <a:p>
             <a:fld id="{FEA1A487-9522-4098-8ABE-F66374D5ED78}" type="datetimeFigureOut">
               <a:rPr lang="en-US" smtClean="0"/>
-              <a:t>2020-12-19</a:t>
+              <a:t>2021-02-01</a:t>
             </a:fld>
             <a:endParaRPr lang="en-US"/>
           </a:p>
@@ -2566,7 +2566,7 @@
           <a:p>
             <a:fld id="{FEA1A487-9522-4098-8ABE-F66374D5ED78}" type="datetimeFigureOut">
               <a:rPr lang="en-US" smtClean="0"/>
-              <a:t>2020-12-19</a:t>
+              <a:t>2021-02-01</a:t>
             </a:fld>
             <a:endParaRPr lang="en-US"/>
           </a:p>
@@ -3705,7 +3705,7 @@
         <p:spPr>
           <a:xfrm>
             <a:off x="160020" y="8811081"/>
-            <a:ext cx="3280410" cy="1631216"/>
+            <a:ext cx="3280410" cy="1877437"/>
           </a:xfrm>
           <a:prstGeom prst="rect">
             <a:avLst/>
@@ -3759,6 +3759,47 @@
               </a:rPr>
               <a:t>2016 - now</a:t>
             </a:r>
+          </a:p>
+          <a:p>
+            <a:pPr marL="285750" indent="-285750">
+              <a:buFont typeface="Wingdings" panose="05000000000000000000" pitchFamily="2" charset="2"/>
+              <a:buChar char="§"/>
+            </a:pPr>
+            <a:r>
+              <a:rPr lang="en-US" sz="1600">
+                <a:solidFill>
+                  <a:schemeClr val="bg1">
+                    <a:lumMod val="85000"/>
+                  </a:schemeClr>
+                </a:solidFill>
+                <a:latin typeface="Poppins Light" panose="00000400000000000000" pitchFamily="2" charset="0"/>
+                <a:cs typeface="Poppins Light" panose="00000400000000000000" pitchFamily="2" charset="0"/>
+              </a:rPr>
+              <a:t>PHP </a:t>
+            </a:r>
+            <a:r>
+              <a:rPr lang="en-US" sz="800">
+                <a:solidFill>
+                  <a:schemeClr val="tx1">
+                    <a:lumMod val="75000"/>
+                    <a:lumOff val="25000"/>
+                  </a:schemeClr>
+                </a:solidFill>
+                <a:latin typeface="Poppins Light" panose="00000400000000000000" pitchFamily="2" charset="0"/>
+                <a:cs typeface="Poppins Light" panose="00000400000000000000" pitchFamily="2" charset="0"/>
+              </a:rPr>
+              <a:t>2015 - 2020</a:t>
+            </a:r>
+            <a:endParaRPr lang="en-US" sz="1600">
+              <a:solidFill>
+                <a:schemeClr val="tx1">
+                  <a:lumMod val="75000"/>
+                  <a:lumOff val="25000"/>
+                </a:schemeClr>
+              </a:solidFill>
+              <a:latin typeface="Poppins Light" panose="00000400000000000000" pitchFamily="2" charset="0"/>
+              <a:cs typeface="Poppins Light" panose="00000400000000000000" pitchFamily="2" charset="0"/>
+            </a:endParaRPr>
           </a:p>
           <a:p>
             <a:pPr marL="285750" indent="-285750">
@@ -4038,8 +4079,8 @@
         </p:nvSpPr>
         <p:spPr>
           <a:xfrm>
-            <a:off x="160020" y="10643598"/>
-            <a:ext cx="3280410" cy="2123658"/>
+            <a:off x="160020" y="11081347"/>
+            <a:ext cx="3280410" cy="1877437"/>
           </a:xfrm>
           <a:prstGeom prst="rect">
             <a:avLst/>
@@ -4093,19 +4134,16 @@
               </a:rPr>
               <a:t>basics</a:t>
             </a:r>
-            <a:r>
-              <a:rPr lang="en-US" sz="1600">
-                <a:solidFill>
-                  <a:schemeClr val="tx1">
-                    <a:lumMod val="75000"/>
-                    <a:lumOff val="25000"/>
-                  </a:schemeClr>
-                </a:solidFill>
-                <a:latin typeface="Poppins Light" panose="00000400000000000000" pitchFamily="2" charset="0"/>
-                <a:cs typeface="Poppins Light" panose="00000400000000000000" pitchFamily="2" charset="0"/>
-              </a:rPr>
-              <a:t> </a:t>
-            </a:r>
+            <a:endParaRPr lang="en-US" sz="1600">
+              <a:solidFill>
+                <a:schemeClr val="tx1">
+                  <a:lumMod val="75000"/>
+                  <a:lumOff val="25000"/>
+                </a:schemeClr>
+              </a:solidFill>
+              <a:latin typeface="Poppins Light" panose="00000400000000000000" pitchFamily="2" charset="0"/>
+              <a:cs typeface="Poppins Light" panose="00000400000000000000" pitchFamily="2" charset="0"/>
+            </a:endParaRPr>
           </a:p>
           <a:p>
             <a:pPr marL="285750" indent="-285750">
@@ -4212,38 +4250,7 @@
                 <a:latin typeface="Poppins Light" panose="00000400000000000000" pitchFamily="2" charset="0"/>
                 <a:cs typeface="Poppins Light" panose="00000400000000000000" pitchFamily="2" charset="0"/>
               </a:rPr>
-              <a:t>Java </a:t>
-            </a:r>
-            <a:r>
-              <a:rPr lang="en-US" sz="800">
-                <a:solidFill>
-                  <a:schemeClr val="tx1">
-                    <a:lumMod val="75000"/>
-                    <a:lumOff val="25000"/>
-                  </a:schemeClr>
-                </a:solidFill>
-                <a:latin typeface="Poppins Light" panose="00000400000000000000" pitchFamily="2" charset="0"/>
-                <a:cs typeface="Poppins Light" panose="00000400000000000000" pitchFamily="2" charset="0"/>
-              </a:rPr>
-              <a:t>basics</a:t>
-            </a:r>
-          </a:p>
-          <a:p>
-            <a:pPr marL="285750" indent="-285750">
-              <a:buFont typeface="Wingdings" panose="05000000000000000000" pitchFamily="2" charset="2"/>
-              <a:buChar char="§"/>
-            </a:pPr>
-            <a:r>
-              <a:rPr lang="en-US" sz="1600">
-                <a:solidFill>
-                  <a:schemeClr val="bg1">
-                    <a:lumMod val="85000"/>
-                  </a:schemeClr>
-                </a:solidFill>
-                <a:latin typeface="Poppins Light" panose="00000400000000000000" pitchFamily="2" charset="0"/>
-                <a:cs typeface="Poppins Light" panose="00000400000000000000" pitchFamily="2" charset="0"/>
-              </a:rPr>
-              <a:t>C++ </a:t>
+              <a:t>C++, Java, Scala </a:t>
             </a:r>
             <a:r>
               <a:rPr lang="en-US" sz="800">
@@ -4536,7 +4543,7 @@
         </p:nvSpPr>
         <p:spPr>
           <a:xfrm>
-            <a:off x="3815862" y="933565"/>
+            <a:off x="3815862" y="2136860"/>
             <a:ext cx="4308230" cy="369332"/>
           </a:xfrm>
           <a:prstGeom prst="rect">
@@ -4574,7 +4581,7 @@
         </p:nvSpPr>
         <p:spPr>
           <a:xfrm>
-            <a:off x="8124092" y="933565"/>
+            <a:off x="8124092" y="2136860"/>
             <a:ext cx="2352308" cy="369332"/>
           </a:xfrm>
           <a:prstGeom prst="rect">
@@ -4613,7 +4620,7 @@
         </p:nvSpPr>
         <p:spPr>
           <a:xfrm>
-            <a:off x="3815862" y="1242155"/>
+            <a:off x="3815862" y="2445450"/>
             <a:ext cx="6660538" cy="338554"/>
           </a:xfrm>
           <a:prstGeom prst="rect">
@@ -4657,7 +4664,7 @@
         </p:nvSpPr>
         <p:spPr>
           <a:xfrm>
-            <a:off x="3815862" y="2160313"/>
+            <a:off x="3815862" y="3363608"/>
             <a:ext cx="4308230" cy="369332"/>
           </a:xfrm>
           <a:prstGeom prst="rect">
@@ -4695,7 +4702,7 @@
         </p:nvSpPr>
         <p:spPr>
           <a:xfrm>
-            <a:off x="8124092" y="2160313"/>
+            <a:off x="8124092" y="3363608"/>
             <a:ext cx="2352308" cy="369332"/>
           </a:xfrm>
           <a:prstGeom prst="rect">
@@ -4734,7 +4741,7 @@
         </p:nvSpPr>
         <p:spPr>
           <a:xfrm>
-            <a:off x="3815862" y="2444469"/>
+            <a:off x="3815862" y="3647764"/>
             <a:ext cx="6660538" cy="338554"/>
           </a:xfrm>
           <a:prstGeom prst="rect">
@@ -4778,7 +4785,7 @@
         </p:nvSpPr>
         <p:spPr>
           <a:xfrm>
-            <a:off x="3827146" y="4407521"/>
+            <a:off x="3827146" y="5422259"/>
             <a:ext cx="4308230" cy="646331"/>
           </a:xfrm>
           <a:prstGeom prst="rect">
@@ -4816,7 +4823,7 @@
         </p:nvSpPr>
         <p:spPr>
           <a:xfrm>
-            <a:off x="8135376" y="4407521"/>
+            <a:off x="8135376" y="5422259"/>
             <a:ext cx="2352308" cy="369332"/>
           </a:xfrm>
           <a:prstGeom prst="rect">
@@ -4855,7 +4862,7 @@
         </p:nvSpPr>
         <p:spPr>
           <a:xfrm>
-            <a:off x="3827146" y="4999127"/>
+            <a:off x="3827146" y="6013865"/>
             <a:ext cx="6660538" cy="584775"/>
           </a:xfrm>
           <a:prstGeom prst="rect">
@@ -4899,7 +4906,7 @@
         </p:nvSpPr>
         <p:spPr>
           <a:xfrm>
-            <a:off x="3827146" y="5822432"/>
+            <a:off x="3827146" y="6837170"/>
             <a:ext cx="4308230" cy="369332"/>
           </a:xfrm>
           <a:prstGeom prst="rect">
@@ -4937,7 +4944,7 @@
         </p:nvSpPr>
         <p:spPr>
           <a:xfrm>
-            <a:off x="8135376" y="5822432"/>
+            <a:off x="8135376" y="6837170"/>
             <a:ext cx="2352308" cy="369332"/>
           </a:xfrm>
           <a:prstGeom prst="rect">
@@ -4976,7 +4983,7 @@
         </p:nvSpPr>
         <p:spPr>
           <a:xfrm>
-            <a:off x="3827146" y="6106588"/>
+            <a:off x="3827146" y="7121326"/>
             <a:ext cx="6660538" cy="338554"/>
           </a:xfrm>
           <a:prstGeom prst="rect">
@@ -5020,7 +5027,7 @@
         </p:nvSpPr>
         <p:spPr>
           <a:xfrm>
-            <a:off x="3827146" y="7656042"/>
+            <a:off x="3827146" y="8670780"/>
             <a:ext cx="4308230" cy="369332"/>
           </a:xfrm>
           <a:prstGeom prst="rect">
@@ -5058,7 +5065,7 @@
         </p:nvSpPr>
         <p:spPr>
           <a:xfrm>
-            <a:off x="3827146" y="7940198"/>
+            <a:off x="3827146" y="8954936"/>
             <a:ext cx="6660538" cy="338554"/>
           </a:xfrm>
           <a:prstGeom prst="rect">
@@ -5101,7 +5108,7 @@
         </p:nvSpPr>
         <p:spPr>
           <a:xfrm>
-            <a:off x="3827146" y="8204747"/>
+            <a:off x="3827146" y="9219485"/>
             <a:ext cx="6660538" cy="1015663"/>
           </a:xfrm>
           <a:prstGeom prst="rect">
@@ -5140,7 +5147,7 @@
         </p:nvSpPr>
         <p:spPr>
           <a:xfrm>
-            <a:off x="3827146" y="9480105"/>
+            <a:off x="3827146" y="10494843"/>
             <a:ext cx="4308230" cy="369332"/>
           </a:xfrm>
           <a:prstGeom prst="rect">
@@ -5178,7 +5185,7 @@
         </p:nvSpPr>
         <p:spPr>
           <a:xfrm>
-            <a:off x="3827146" y="9757548"/>
+            <a:off x="3827146" y="10772286"/>
             <a:ext cx="6660538" cy="338554"/>
           </a:xfrm>
           <a:prstGeom prst="rect">
@@ -5221,7 +5228,7 @@
         </p:nvSpPr>
         <p:spPr>
           <a:xfrm>
-            <a:off x="3827146" y="10028810"/>
+            <a:off x="3827146" y="11043548"/>
             <a:ext cx="6660538" cy="646331"/>
           </a:xfrm>
           <a:prstGeom prst="rect">
@@ -5260,7 +5267,7 @@
         </p:nvSpPr>
         <p:spPr>
           <a:xfrm>
-            <a:off x="3827146" y="10939690"/>
+            <a:off x="3827146" y="11800524"/>
             <a:ext cx="4308230" cy="369332"/>
           </a:xfrm>
           <a:prstGeom prst="rect">
@@ -5298,7 +5305,7 @@
         </p:nvSpPr>
         <p:spPr>
           <a:xfrm>
-            <a:off x="3827146" y="11223846"/>
+            <a:off x="3827146" y="12084680"/>
             <a:ext cx="6660538" cy="338554"/>
           </a:xfrm>
           <a:prstGeom prst="rect">
@@ -5323,45 +5330,6 @@
                 <a:cs typeface="Poppins Light" panose="00000400000000000000" pitchFamily="2" charset="0"/>
               </a:rPr>
               <a:t>HTML, CSS, Bootstrap</a:t>
-            </a:r>
-          </a:p>
-        </p:txBody>
-      </p:sp>
-      <p:sp>
-        <p:nvSpPr>
-          <p:cNvPr id="68" name="pole tekstowe 67">
-            <a:extLst>
-              <a:ext uri="{FF2B5EF4-FFF2-40B4-BE49-F238E27FC236}">
-                <a16:creationId xmlns:a16="http://schemas.microsoft.com/office/drawing/2014/main" id="{E39D167A-C1DD-4779-87EA-C207688A6867}"/>
-              </a:ext>
-            </a:extLst>
-          </p:cNvPr>
-          <p:cNvSpPr txBox="1"/>
-          <p:nvPr/>
-        </p:nvSpPr>
-        <p:spPr>
-          <a:xfrm>
-            <a:off x="3827146" y="11488395"/>
-            <a:ext cx="6660538" cy="276999"/>
-          </a:xfrm>
-          <a:prstGeom prst="rect">
-            <a:avLst/>
-          </a:prstGeom>
-          <a:noFill/>
-        </p:spPr>
-        <p:txBody>
-          <a:bodyPr wrap="square" rtlCol="0">
-            <a:spAutoFit/>
-          </a:bodyPr>
-          <a:lstStyle/>
-          <a:p>
-            <a:pPr algn="just"/>
-            <a:r>
-              <a:rPr lang="en-US" sz="1200">
-                <a:latin typeface="Poppins Light" panose="00000400000000000000" pitchFamily="2" charset="0"/>
-                <a:cs typeface="Poppins Light" panose="00000400000000000000" pitchFamily="2" charset="0"/>
-              </a:rPr>
-              <a:t>Scorpion Dance Team website.</a:t>
             </a:r>
           </a:p>
         </p:txBody>
@@ -5380,7 +5348,7 @@
         </p:nvSpPr>
         <p:spPr>
           <a:xfrm>
-            <a:off x="3827146" y="12021628"/>
+            <a:off x="3827146" y="12526640"/>
             <a:ext cx="4308230" cy="369332"/>
           </a:xfrm>
           <a:prstGeom prst="rect">
@@ -5418,7 +5386,7 @@
         </p:nvSpPr>
         <p:spPr>
           <a:xfrm>
-            <a:off x="3827146" y="12305784"/>
+            <a:off x="3827146" y="12810796"/>
             <a:ext cx="6660538" cy="338554"/>
           </a:xfrm>
           <a:prstGeom prst="rect">
@@ -5443,45 +5411,6 @@
                 <a:cs typeface="Poppins Light" panose="00000400000000000000" pitchFamily="2" charset="0"/>
               </a:rPr>
               <a:t>Python, Django, HTML, CSS, Bootstrap</a:t>
-            </a:r>
-          </a:p>
-        </p:txBody>
-      </p:sp>
-      <p:sp>
-        <p:nvSpPr>
-          <p:cNvPr id="72" name="pole tekstowe 71">
-            <a:extLst>
-              <a:ext uri="{FF2B5EF4-FFF2-40B4-BE49-F238E27FC236}">
-                <a16:creationId xmlns:a16="http://schemas.microsoft.com/office/drawing/2014/main" id="{BBDB1A1B-A7C4-44E8-B2C3-9DEDA8D2E28D}"/>
-              </a:ext>
-            </a:extLst>
-          </p:cNvPr>
-          <p:cNvSpPr txBox="1"/>
-          <p:nvPr/>
-        </p:nvSpPr>
-        <p:spPr>
-          <a:xfrm>
-            <a:off x="3827146" y="12570333"/>
-            <a:ext cx="6660538" cy="461665"/>
-          </a:xfrm>
-          <a:prstGeom prst="rect">
-            <a:avLst/>
-          </a:prstGeom>
-          <a:noFill/>
-        </p:spPr>
-        <p:txBody>
-          <a:bodyPr wrap="square" rtlCol="0">
-            <a:spAutoFit/>
-          </a:bodyPr>
-          <a:lstStyle/>
-          <a:p>
-            <a:pPr algn="just"/>
-            <a:r>
-              <a:rPr lang="en-US" sz="1200">
-                <a:latin typeface="Poppins Light" panose="00000400000000000000" pitchFamily="2" charset="0"/>
-                <a:cs typeface="Poppins Light" panose="00000400000000000000" pitchFamily="2" charset="0"/>
-              </a:rPr>
-              <a:t>Application that searches for the shortest route between two stops in Solvro City. Including user authentication, user interface, API and city map visualization.</a:t>
             </a:r>
           </a:p>
         </p:txBody>
@@ -5793,7 +5722,7 @@
         </p:nvSpPr>
         <p:spPr>
           <a:xfrm>
-            <a:off x="3827146" y="1528436"/>
+            <a:off x="3827146" y="2731731"/>
             <a:ext cx="6660538" cy="461665"/>
           </a:xfrm>
           <a:prstGeom prst="rect">
@@ -5832,7 +5761,7 @@
         </p:nvSpPr>
         <p:spPr>
           <a:xfrm>
-            <a:off x="3827146" y="2739006"/>
+            <a:off x="3827146" y="3942301"/>
             <a:ext cx="6660538" cy="461665"/>
           </a:xfrm>
           <a:prstGeom prst="rect">
@@ -5871,7 +5800,7 @@
         </p:nvSpPr>
         <p:spPr>
           <a:xfrm>
-            <a:off x="3600451" y="3618741"/>
+            <a:off x="3600451" y="4633479"/>
             <a:ext cx="2290760" cy="544522"/>
           </a:xfrm>
           <a:prstGeom prst="rect">
@@ -5923,7 +5852,7 @@
         </p:nvSpPr>
         <p:spPr>
           <a:xfrm>
-            <a:off x="3815862" y="3667165"/>
+            <a:off x="3815862" y="4681903"/>
             <a:ext cx="6660538" cy="461665"/>
           </a:xfrm>
           <a:prstGeom prst="rect">
@@ -5975,7 +5904,7 @@
         </p:nvSpPr>
         <p:spPr>
           <a:xfrm>
-            <a:off x="3600450" y="6864779"/>
+            <a:off x="3600450" y="7879517"/>
             <a:ext cx="2283617" cy="544522"/>
           </a:xfrm>
           <a:prstGeom prst="rect">
@@ -6027,7 +5956,7 @@
         </p:nvSpPr>
         <p:spPr>
           <a:xfrm>
-            <a:off x="3815862" y="6913203"/>
+            <a:off x="3815862" y="7927941"/>
             <a:ext cx="6660538" cy="461665"/>
           </a:xfrm>
           <a:prstGeom prst="rect">
@@ -6183,7 +6112,7 @@
         </p:nvSpPr>
         <p:spPr>
           <a:xfrm>
-            <a:off x="8135376" y="7657353"/>
+            <a:off x="8135376" y="8672091"/>
             <a:ext cx="2352308" cy="369332"/>
           </a:xfrm>
           <a:prstGeom prst="rect">
@@ -6222,7 +6151,7 @@
         </p:nvSpPr>
         <p:spPr>
           <a:xfrm>
-            <a:off x="8135376" y="9485027"/>
+            <a:off x="8135376" y="10499765"/>
             <a:ext cx="2352308" cy="369332"/>
           </a:xfrm>
           <a:prstGeom prst="rect">
@@ -6261,7 +6190,7 @@
         </p:nvSpPr>
         <p:spPr>
           <a:xfrm>
-            <a:off x="8135376" y="10946669"/>
+            <a:off x="8135376" y="11807503"/>
             <a:ext cx="2352308" cy="369332"/>
           </a:xfrm>
           <a:prstGeom prst="rect">
@@ -6300,7 +6229,7 @@
         </p:nvSpPr>
         <p:spPr>
           <a:xfrm>
-            <a:off x="8135376" y="12023281"/>
+            <a:off x="8135376" y="12528293"/>
             <a:ext cx="2352308" cy="369332"/>
           </a:xfrm>
           <a:prstGeom prst="rect">
@@ -6321,6 +6250,166 @@
                 <a:cs typeface="Poppins SemiBold" panose="00000700000000000000" pitchFamily="2" charset="0"/>
               </a:rPr>
               <a:t>2020</a:t>
+            </a:r>
+          </a:p>
+        </p:txBody>
+      </p:sp>
+      <p:sp>
+        <p:nvSpPr>
+          <p:cNvPr id="74" name="pole tekstowe 73">
+            <a:extLst>
+              <a:ext uri="{FF2B5EF4-FFF2-40B4-BE49-F238E27FC236}">
+                <a16:creationId xmlns:a16="http://schemas.microsoft.com/office/drawing/2014/main" id="{6827B56B-6959-4D7D-B426-C8F673727827}"/>
+              </a:ext>
+            </a:extLst>
+          </p:cNvPr>
+          <p:cNvSpPr txBox="1"/>
+          <p:nvPr/>
+        </p:nvSpPr>
+        <p:spPr>
+          <a:xfrm>
+            <a:off x="3815862" y="879451"/>
+            <a:ext cx="4308230" cy="369332"/>
+          </a:xfrm>
+          <a:prstGeom prst="rect">
+            <a:avLst/>
+          </a:prstGeom>
+          <a:noFill/>
+        </p:spPr>
+        <p:txBody>
+          <a:bodyPr wrap="square" rtlCol="0">
+            <a:spAutoFit/>
+          </a:bodyPr>
+          <a:lstStyle/>
+          <a:p>
+            <a:r>
+              <a:rPr lang="en-US">
+                <a:latin typeface="Poppins SemiBold" panose="00000700000000000000" pitchFamily="2" charset="0"/>
+                <a:cs typeface="Poppins SemiBold" panose="00000700000000000000" pitchFamily="2" charset="0"/>
+              </a:rPr>
+              <a:t>Python Developer</a:t>
+            </a:r>
+          </a:p>
+        </p:txBody>
+      </p:sp>
+      <p:sp>
+        <p:nvSpPr>
+          <p:cNvPr id="76" name="pole tekstowe 75">
+            <a:extLst>
+              <a:ext uri="{FF2B5EF4-FFF2-40B4-BE49-F238E27FC236}">
+                <a16:creationId xmlns:a16="http://schemas.microsoft.com/office/drawing/2014/main" id="{65335A40-377E-490A-9F8F-991495922CEF}"/>
+              </a:ext>
+            </a:extLst>
+          </p:cNvPr>
+          <p:cNvSpPr txBox="1"/>
+          <p:nvPr/>
+        </p:nvSpPr>
+        <p:spPr>
+          <a:xfrm>
+            <a:off x="8124092" y="879451"/>
+            <a:ext cx="2352308" cy="369332"/>
+          </a:xfrm>
+          <a:prstGeom prst="rect">
+            <a:avLst/>
+          </a:prstGeom>
+          <a:noFill/>
+        </p:spPr>
+        <p:txBody>
+          <a:bodyPr wrap="square" rtlCol="0">
+            <a:spAutoFit/>
+          </a:bodyPr>
+          <a:lstStyle/>
+          <a:p>
+            <a:pPr algn="r"/>
+            <a:r>
+              <a:rPr lang="en-US" b="1">
+                <a:latin typeface="Poppins SemiBold" panose="00000700000000000000" pitchFamily="2" charset="0"/>
+                <a:cs typeface="Poppins SemiBold" panose="00000700000000000000" pitchFamily="2" charset="0"/>
+              </a:rPr>
+              <a:t>02.2021 - now</a:t>
+            </a:r>
+          </a:p>
+        </p:txBody>
+      </p:sp>
+      <p:sp>
+        <p:nvSpPr>
+          <p:cNvPr id="77" name="pole tekstowe 76">
+            <a:extLst>
+              <a:ext uri="{FF2B5EF4-FFF2-40B4-BE49-F238E27FC236}">
+                <a16:creationId xmlns:a16="http://schemas.microsoft.com/office/drawing/2014/main" id="{DCF64990-CD5E-4007-B99A-34CED401CC76}"/>
+              </a:ext>
+            </a:extLst>
+          </p:cNvPr>
+          <p:cNvSpPr txBox="1"/>
+          <p:nvPr/>
+        </p:nvSpPr>
+        <p:spPr>
+          <a:xfrm>
+            <a:off x="3815862" y="1188041"/>
+            <a:ext cx="6660538" cy="338554"/>
+          </a:xfrm>
+          <a:prstGeom prst="rect">
+            <a:avLst/>
+          </a:prstGeom>
+          <a:noFill/>
+        </p:spPr>
+        <p:txBody>
+          <a:bodyPr wrap="square" rtlCol="0">
+            <a:spAutoFit/>
+          </a:bodyPr>
+          <a:lstStyle/>
+          <a:p>
+            <a:pPr algn="just"/>
+            <a:r>
+              <a:rPr lang="en-US" sz="1600">
+                <a:solidFill>
+                  <a:schemeClr val="bg1">
+                    <a:lumMod val="50000"/>
+                  </a:schemeClr>
+                </a:solidFill>
+                <a:latin typeface="Poppins Light" panose="00000400000000000000" pitchFamily="2" charset="0"/>
+                <a:cs typeface="Poppins Light" panose="00000400000000000000" pitchFamily="2" charset="0"/>
+              </a:rPr>
+              <a:t>Seargin by order of Roche (Contract)</a:t>
+            </a:r>
+          </a:p>
+        </p:txBody>
+      </p:sp>
+      <p:sp>
+        <p:nvSpPr>
+          <p:cNvPr id="87" name="pole tekstowe 86">
+            <a:extLst>
+              <a:ext uri="{FF2B5EF4-FFF2-40B4-BE49-F238E27FC236}">
+                <a16:creationId xmlns:a16="http://schemas.microsoft.com/office/drawing/2014/main" id="{E3E15890-76FB-4A78-906F-6031ACD8285C}"/>
+              </a:ext>
+            </a:extLst>
+          </p:cNvPr>
+          <p:cNvSpPr txBox="1"/>
+          <p:nvPr/>
+        </p:nvSpPr>
+        <p:spPr>
+          <a:xfrm>
+            <a:off x="3827146" y="1474322"/>
+            <a:ext cx="6660538" cy="461665"/>
+          </a:xfrm>
+          <a:prstGeom prst="rect">
+            <a:avLst/>
+          </a:prstGeom>
+          <a:noFill/>
+        </p:spPr>
+        <p:txBody>
+          <a:bodyPr wrap="square" rtlCol="0">
+            <a:spAutoFit/>
+          </a:bodyPr>
+          <a:lstStyle/>
+          <a:p>
+            <a:pPr algn="just"/>
+            <a:r>
+              <a:rPr lang="en-US" sz="1200">
+                <a:latin typeface="Poppins Light" panose="00000400000000000000" pitchFamily="2" charset="0"/>
+                <a:cs typeface="Poppins Light" panose="00000400000000000000" pitchFamily="2" charset="0"/>
+              </a:rPr>
+              <a:t>Developing, designing, implementing and documenting applications with Python at the backend.</a:t>
             </a:r>
           </a:p>
         </p:txBody>

</xml_diff>